<commit_message>
Changes in validation app and manual for it. Result file Handling is now improved: User gets a warning, if there is already an existing results.csv file, that would be overwritten. Now the user can also use external drives.
</commit_message>
<xml_diff>
--- a/flowchart_package_workflow.pptx
+++ b/flowchart_package_workflow.pptx
@@ -261,7 +261,7 @@
           <a:p>
             <a:fld id="{E9E2B78C-852E-44CB-AA05-3A4EE16E8ABD}" type="datetimeFigureOut">
               <a:rPr lang="en-DE" smtClean="0"/>
-              <a:t>05/09/2025</a:t>
+              <a:t>02/10/2025</a:t>
             </a:fld>
             <a:endParaRPr lang="en-DE"/>
           </a:p>
@@ -461,7 +461,7 @@
           <a:p>
             <a:fld id="{E9E2B78C-852E-44CB-AA05-3A4EE16E8ABD}" type="datetimeFigureOut">
               <a:rPr lang="en-DE" smtClean="0"/>
-              <a:t>05/09/2025</a:t>
+              <a:t>02/10/2025</a:t>
             </a:fld>
             <a:endParaRPr lang="en-DE"/>
           </a:p>
@@ -671,7 +671,7 @@
           <a:p>
             <a:fld id="{E9E2B78C-852E-44CB-AA05-3A4EE16E8ABD}" type="datetimeFigureOut">
               <a:rPr lang="en-DE" smtClean="0"/>
-              <a:t>05/09/2025</a:t>
+              <a:t>02/10/2025</a:t>
             </a:fld>
             <a:endParaRPr lang="en-DE"/>
           </a:p>
@@ -871,7 +871,7 @@
           <a:p>
             <a:fld id="{E9E2B78C-852E-44CB-AA05-3A4EE16E8ABD}" type="datetimeFigureOut">
               <a:rPr lang="en-DE" smtClean="0"/>
-              <a:t>05/09/2025</a:t>
+              <a:t>02/10/2025</a:t>
             </a:fld>
             <a:endParaRPr lang="en-DE"/>
           </a:p>
@@ -1147,7 +1147,7 @@
           <a:p>
             <a:fld id="{E9E2B78C-852E-44CB-AA05-3A4EE16E8ABD}" type="datetimeFigureOut">
               <a:rPr lang="en-DE" smtClean="0"/>
-              <a:t>05/09/2025</a:t>
+              <a:t>02/10/2025</a:t>
             </a:fld>
             <a:endParaRPr lang="en-DE"/>
           </a:p>
@@ -1415,7 +1415,7 @@
           <a:p>
             <a:fld id="{E9E2B78C-852E-44CB-AA05-3A4EE16E8ABD}" type="datetimeFigureOut">
               <a:rPr lang="en-DE" smtClean="0"/>
-              <a:t>05/09/2025</a:t>
+              <a:t>02/10/2025</a:t>
             </a:fld>
             <a:endParaRPr lang="en-DE"/>
           </a:p>
@@ -1830,7 +1830,7 @@
           <a:p>
             <a:fld id="{E9E2B78C-852E-44CB-AA05-3A4EE16E8ABD}" type="datetimeFigureOut">
               <a:rPr lang="en-DE" smtClean="0"/>
-              <a:t>05/09/2025</a:t>
+              <a:t>02/10/2025</a:t>
             </a:fld>
             <a:endParaRPr lang="en-DE"/>
           </a:p>
@@ -1972,7 +1972,7 @@
           <a:p>
             <a:fld id="{E9E2B78C-852E-44CB-AA05-3A4EE16E8ABD}" type="datetimeFigureOut">
               <a:rPr lang="en-DE" smtClean="0"/>
-              <a:t>05/09/2025</a:t>
+              <a:t>02/10/2025</a:t>
             </a:fld>
             <a:endParaRPr lang="en-DE"/>
           </a:p>
@@ -2085,7 +2085,7 @@
           <a:p>
             <a:fld id="{E9E2B78C-852E-44CB-AA05-3A4EE16E8ABD}" type="datetimeFigureOut">
               <a:rPr lang="en-DE" smtClean="0"/>
-              <a:t>05/09/2025</a:t>
+              <a:t>02/10/2025</a:t>
             </a:fld>
             <a:endParaRPr lang="en-DE"/>
           </a:p>
@@ -2398,7 +2398,7 @@
           <a:p>
             <a:fld id="{E9E2B78C-852E-44CB-AA05-3A4EE16E8ABD}" type="datetimeFigureOut">
               <a:rPr lang="en-DE" smtClean="0"/>
-              <a:t>05/09/2025</a:t>
+              <a:t>02/10/2025</a:t>
             </a:fld>
             <a:endParaRPr lang="en-DE"/>
           </a:p>
@@ -2687,7 +2687,7 @@
           <a:p>
             <a:fld id="{E9E2B78C-852E-44CB-AA05-3A4EE16E8ABD}" type="datetimeFigureOut">
               <a:rPr lang="en-DE" smtClean="0"/>
-              <a:t>05/09/2025</a:t>
+              <a:t>02/10/2025</a:t>
             </a:fld>
             <a:endParaRPr lang="en-DE"/>
           </a:p>
@@ -2930,7 +2930,7 @@
           <a:p>
             <a:fld id="{E9E2B78C-852E-44CB-AA05-3A4EE16E8ABD}" type="datetimeFigureOut">
               <a:rPr lang="en-DE" smtClean="0"/>
-              <a:t>05/09/2025</a:t>
+              <a:t>02/10/2025</a:t>
             </a:fld>
             <a:endParaRPr lang="en-DE"/>
           </a:p>

</xml_diff>